<commit_message>
Revert "Merge branch 'ending-slide' into fix-validation"
This reverts commit 481c97781a5702da31a5d54da4bd828a43939de1, reversing
changes made to e3e81bf9ae2c65def3c6b7660798766498e6f383.
</commit_message>
<xml_diff>
--- a/Current Presentation/Spring 2026.pptx
+++ b/Current Presentation/Spring 2026.pptx
@@ -5,7 +5,7 @@
     <p:sldMasterId id="2147483660" r:id="rId1"/>
   </p:sldMasterIdLst>
   <p:notesMasterIdLst>
-    <p:notesMasterId r:id="rId9"/>
+    <p:notesMasterId r:id="rId8"/>
   </p:notesMasterIdLst>
   <p:sldIdLst>
     <p:sldId id="260" r:id="rId2"/>
@@ -14,7 +14,6 @@
     <p:sldId id="263" r:id="rId5"/>
     <p:sldId id="264" r:id="rId6"/>
     <p:sldId id="265" r:id="rId7"/>
-    <p:sldId id="266" r:id="rId8"/>
   </p:sldIdLst>
   <p:sldSz cx="12192000" cy="6858000"/>
   <p:notesSz cx="6858000" cy="9144000"/>
@@ -124,7 +123,6 @@
             <p14:sldId id="263"/>
             <p14:sldId id="264"/>
             <p14:sldId id="265"/>
-            <p14:sldId id="266"/>
           </p14:sldIdLst>
         </p14:section>
       </p14:sectionLst>
@@ -137,7 +135,7 @@
 <p1510:revInfo xmlns:a="http://schemas.openxmlformats.org/drawingml/2006/main" xmlns:r="http://schemas.openxmlformats.org/officeDocument/2006/relationships" xmlns:p1510="http://schemas.microsoft.com/office/powerpoint/2015/10/main">
   <p1510:revLst>
     <p1510:client id="{6998B00B-2615-DA7F-16DD-BEDBD145F26F}" v="169" dt="2026-06-22T15:38:36.746"/>
-    <p1510:client id="{BA9E5608-3EA5-4EB9-B58B-23EA90833BA8}" v="3" dt="2026-06-22T16:38:41.075"/>
+    <p1510:client id="{BA9E5608-3EA5-4EB9-B58B-23EA90833BA8}" v="2" dt="2026-06-22T16:31:05.899"/>
     <p1510:client id="{ECBCC7A4-2B2E-30B8-636B-1ED04629B37E}" v="53" dt="2026-06-22T16:20:29.604"/>
   </p1510:revLst>
 </p1510:revInfo>
@@ -8425,159 +8423,6 @@
     <a:masterClrMapping/>
   </p:clrMapOvr>
   <p:transition advClick="0"/>
-</p:sld>
-</file>
-
-<file path=ppt/slides/slide7.xml><?xml version="1.0" encoding="utf-8"?>
-<p:sld xmlns:a="http://schemas.openxmlformats.org/drawingml/2006/main" xmlns:r="http://schemas.openxmlformats.org/officeDocument/2006/relationships" xmlns:p="http://schemas.openxmlformats.org/presentationml/2006/main">
-  <p:cSld>
-    <p:spTree>
-      <p:nvGrpSpPr>
-        <p:cNvPr id="1" name=""/>
-        <p:cNvGrpSpPr/>
-        <p:nvPr/>
-      </p:nvGrpSpPr>
-      <p:grpSpPr>
-        <a:xfrm>
-          <a:off x="0" y="0"/>
-          <a:ext cx="0" cy="0"/>
-          <a:chOff x="0" y="0"/>
-          <a:chExt cx="0" cy="0"/>
-        </a:xfrm>
-      </p:grpSpPr>
-      <p:sp>
-        <p:nvSpPr>
-          <p:cNvPr id="2" name="Notes TextBox"/>
-          <p:cNvSpPr txBox="1"/>
-          <p:nvPr/>
-        </p:nvSpPr>
-        <p:spPr>
-          <a:xfrm>
-            <a:off x="457200" y="304800"/>
-            <a:ext cx="11277600" cy="6248400"/>
-          </a:xfrm>
-          <a:prstGeom prst="rect">
-            <a:avLst/>
-          </a:prstGeom>
-          <a:noFill/>
-        </p:spPr>
-        <p:txBody>
-          <a:bodyPr wrap="square" rtlCol="0">
-            <a:normAutofit/>
-          </a:bodyPr>
-          <a:lstStyle/>
-          <a:p>
-            <a:r>
-              <a:rPr lang="en-US" sz="1400" b="1" dirty="0"/>
-              <a:t>VALIDATION NOTES — context for a future fix (nothing has been fixed yet)</a:t>
-            </a:r>
-          </a:p>
-          <a:p>
-            <a:endParaRPr lang="en-US" sz="700" dirty="0"/>
-          </a:p>
-          <a:p>
-            <a:r>
-              <a:rPr lang="en-US" sz="1050" b="1" dirty="0"/>
-              <a:t>ERROR (verbatim from packer): </a:t>
-            </a:r>
-            <a:r>
-              <a:rPr lang="en-US" sz="1050" dirty="0"/>
-              <a:t>ppt/slides/slide_104_C9102F9E.xml — Element '{http://schemas.openxmlformats.org/presentationml/2006/main}contentPart': Character content is not allowed, because the content type is empty.</a:t>
-            </a:r>
-          </a:p>
-          <a:p>
-            <a:endParaRPr lang="en-US" sz="700" dirty="0"/>
-          </a:p>
-          <a:p>
-            <a:r>
-              <a:rPr lang="en-US" sz="1050" b="1" dirty="0"/>
-              <a:t>ROOT CAUSE: </a:t>
-            </a:r>
-            <a:r>
-              <a:rPr lang="en-US" sz="1050" dirty="0"/>
-              <a:t>Visible slide 4 contains a &lt;p:contentPart&gt; element (a digital-ink annotation). The OOXML schema the validator uses declares p:contentPart as an EMPTY content type, so it permits no character data at all. When the .pptx is unpacked, the XML is pretty-printed, which inserts newline + indentation whitespace BETWEEN the contentPart's child tags. That whitespace counts as "character content" inside an element the schema says must be empty, so validation fails. This is a cosmetic schema-strictness quirk caused by pretty-printing, NOT real corruption — PowerPoint opens the file normally. The deck was therefore packed with --skip-validation.</a:t>
-            </a:r>
-          </a:p>
-          <a:p>
-            <a:endParaRPr lang="en-US" sz="700" dirty="0"/>
-          </a:p>
-          <a:p>
-            <a:r>
-              <a:rPr lang="en-US" sz="1050" b="1" dirty="0"/>
-              <a:t>AFFECTED PART: </a:t>
-            </a:r>
-            <a:r>
-              <a:rPr lang="en-US" sz="1050" dirty="0"/>
-              <a:t>ppt/slides/slide_104_C9102F9E.xml (visible slide 4); the offending node is the &lt;p:contentPart ... r:id="rId2"&gt; block.</a:t>
-            </a:r>
-          </a:p>
-          <a:p>
-            <a:endParaRPr lang="en-US" sz="700" dirty="0"/>
-          </a:p>
-          <a:p>
-            <a:r>
-              <a:rPr lang="en-US" sz="1050" b="1" dirty="0"/>
-              <a:t>POSSIBLE FIXES (pick one):</a:t>
-            </a:r>
-          </a:p>
-          <a:p>
-            <a:r>
-              <a:rPr lang="en-US" sz="1050" dirty="0"/>
-              <a:t>1. Minify just the contentPart element so no whitespace text nodes sit between its child tags.</a:t>
-            </a:r>
-          </a:p>
-          <a:p>
-            <a:r>
-              <a:rPr lang="en-US" sz="1050" dirty="0"/>
-              <a:t>2. Delete the contentPart, its rId2 relationship, and ppt/ink/ink_104_C9102F9E.xml if the ink stroke is unwanted.</a:t>
-            </a:r>
-          </a:p>
-          <a:p>
-            <a:r>
-              <a:rPr lang="en-US" sz="1050" dirty="0"/>
-              <a:t>3. Leave as-is and keep packing with --skip-validation (the file is valid for PowerPoint).</a:t>
-            </a:r>
-          </a:p>
-          <a:p>
-            <a:endParaRPr lang="en-US" sz="700" dirty="0"/>
-          </a:p>
-          <a:p>
-            <a:r>
-              <a:rPr lang="en-US" sz="1050" b="1" dirty="0"/>
-              <a:t>THE ANNOTATION ("that annotation thing"):</a:t>
-            </a:r>
-          </a:p>
-          <a:p>
-            <a:r>
-              <a:rPr lang="en-US" sz="1050" dirty="0"/>
-              <a:t>- Type: digital ink / pen stroke (InkML), surfaced as &lt;p:contentPart name="Ink 3"&gt; on slide 4.</a:t>
-            </a:r>
-          </a:p>
-          <a:p>
-            <a:r>
-              <a:rPr lang="en-US" sz="1050" dirty="0"/>
-              <a:t>- Ink data file: ppt/ink/ink_104_C9102F9E.xml; drawn 2026-06-15T16:24:39 with a 0.035 cm pen.</a:t>
-            </a:r>
-          </a:p>
-          <a:p>
-            <a:r>
-              <a:rPr lang="en-US" sz="1050" dirty="0"/>
-              <a:t>- Geometry on slide: offset x=1133175 y=3095550 EMU, size 360x360 EMU (~0.0004 in) — effectively a single dot.</a:t>
-            </a:r>
-          </a:p>
-          <a:p>
-            <a:r>
-              <a:rPr lang="en-US" sz="1050" dirty="0"/>
-              <a:t>- Trace contents (verbatim): 0 0 24575,'0'0'-8191 — one point, i.e. an accidental tap/dot, not a meaningful drawing.</a:t>
-            </a:r>
-          </a:p>
-        </p:txBody>
-      </p:sp>
-    </p:spTree>
-  </p:cSld>
-  <p:clrMapOvr>
-    <a:masterClrMapping/>
-  </p:clrMapOvr>
 </p:sld>
 </file>
 

</xml_diff>

<commit_message>
Revert "Merge branch 'Spring-2026' into ending-slide-2.0"
This reverts commit d0e98d3e7ba47edf6fa8dec860ca0729f89fd5e8, reversing
changes made to 9f679c153c3ccbf68c885aeac6dea5c4bcf066ea.
</commit_message>
<xml_diff>
--- a/Current Presentation/Spring 2026.pptx
+++ b/Current Presentation/Spring 2026.pptx
@@ -5,7 +5,7 @@
     <p:sldMasterId id="2147483660" r:id="rId1"/>
   </p:sldMasterIdLst>
   <p:notesMasterIdLst>
-    <p:notesMasterId r:id="rId9"/>
+    <p:notesMasterId r:id="rId7"/>
   </p:notesMasterIdLst>
   <p:sldIdLst>
     <p:sldId id="260" r:id="rId2"/>
@@ -13,8 +13,6 @@
     <p:sldId id="262" r:id="rId4"/>
     <p:sldId id="263" r:id="rId5"/>
     <p:sldId id="264" r:id="rId6"/>
-    <p:sldId id="266" r:id="rId7"/>
-    <p:sldId id="265" r:id="rId8"/>
   </p:sldIdLst>
   <p:sldSz cx="12192000" cy="6858000"/>
   <p:notesSz cx="6858000" cy="9144000"/>
@@ -114,20 +112,8 @@
     </a:lvl9pPr>
   </p:defaultTextStyle>
   <p:extLst>
-    <p:ext uri="{521415D9-36F7-43E2-AB2F-B90AF26B5E84}">
-      <p14:sectionLst xmlns:p14="http://schemas.microsoft.com/office/powerpoint/2010/main">
-        <p14:section name="Default Section" id="{6B736126-433D-4E27-8CA2-964397748075}">
-          <p14:sldIdLst>
-            <p14:sldId id="260"/>
-            <p14:sldId id="261"/>
-            <p14:sldId id="262"/>
-            <p14:sldId id="263"/>
-            <p14:sldId id="264"/>
-            <p14:sldId id="266"/>
-            <p14:sldId id="265"/>
-          </p14:sldIdLst>
-        </p14:section>
-      </p14:sectionLst>
+    <p:ext uri="{EFAFB233-063F-42B5-8137-9DF3F51BA10A}">
+      <p15:sldGuideLst xmlns:p15="http://schemas.microsoft.com/office/powerpoint/2012/main"/>
     </p:ext>
   </p:extLst>
 </p:presentation>
@@ -136,9 +122,7 @@
 <file path=ppt/revisionInfo.xml><?xml version="1.0" encoding="utf-8"?>
 <p1510:revInfo xmlns:a="http://schemas.openxmlformats.org/drawingml/2006/main" xmlns:r="http://schemas.openxmlformats.org/officeDocument/2006/relationships" xmlns:p1510="http://schemas.microsoft.com/office/powerpoint/2015/10/main">
   <p1510:revLst>
-    <p1510:client id="{6998B00B-2615-DA7F-16DD-BEDBD145F26F}" v="169" dt="2026-06-22T15:38:36.746"/>
-    <p1510:client id="{BA9E5608-3EA5-4EB9-B58B-23EA90833BA8}" v="731" dt="2026-06-22T16:59:33.224"/>
-    <p1510:client id="{ECBCC7A4-2B2E-30B8-636B-1ED04629B37E}" v="53" dt="2026-06-22T16:20:29.604"/>
+    <p1510:client id="{6998B00B-2615-DA7F-16DD-BEDBD145F26F}" v="142" dt="2026-06-22T15:26:48.182"/>
   </p1510:revLst>
 </p1510:revInfo>
 </file>
@@ -167,126 +151,6 @@
     </inkml:brush>
   </inkml:definitions>
   <inkml:trace contextRef="#ctx0" brushRef="#br0">0 0 24575,'0'0'-8191</inkml:trace>
-</inkml:ink>
-</file>
-
-<file path=ppt/ink/ink2.xml><?xml version="1.0" encoding="utf-8"?>
-<inkml:ink xmlns:inkml="http://www.w3.org/2003/InkML">
-  <inkml:definitions>
-    <inkml:context xml:id="ctx0">
-      <inkml:inkSource xml:id="inkSrc0">
-        <inkml:traceFormat>
-          <inkml:channel name="X" type="integer" min="-2.14748E9" max="2.14748E9" units="cm"/>
-          <inkml:channel name="Y" type="integer" min="-2.14748E9" max="2.14748E9" units="cm"/>
-          <inkml:channel name="F" type="integer" max="32767" units="dev"/>
-          <inkml:channel name="OA" type="integer" max="360" units="deg"/>
-          <inkml:channel name="OE" type="integer" max="90" units="deg"/>
-        </inkml:traceFormat>
-        <inkml:channelProperties>
-          <inkml:channelProperty channel="X" name="resolution" value="1000" units="1/cm"/>
-          <inkml:channelProperty channel="Y" name="resolution" value="1000" units="1/cm"/>
-          <inkml:channelProperty channel="F" name="resolution" value="0" units="1/dev"/>
-          <inkml:channelProperty channel="OA" name="resolution" value="1000" units="1/deg"/>
-          <inkml:channelProperty channel="OE" name="resolution" value="1000" units="1/deg"/>
-        </inkml:channelProperties>
-      </inkml:inkSource>
-    </inkml:context>
-    <inkml:brush xml:id="br0">
-      <inkml:brushProperty name="width" value="0.1" units="cm"/>
-      <inkml:brushProperty name="height" value="0.1" units="cm"/>
-    </inkml:brush>
-  </inkml:definitions>
-  <inkml:trace contextRef="#ctx0" brushRef="#br0">12415 4842 16383 0 0,'0'8'0'0'0,"0"12"0"0"0,-4 7 0 0 0,-2 3 0 0 0,1 0 0 0 0,1 0 0 0 0,1-1 0 0 0,-4-2 0 0 0,1 0 0 0 0,0-1 0 0 0,1 0 0 0 0,-2 12 0 0 0,0 4 0 0 0,1 8 0 0 0,-3 16 0 0 0,-4 11 0 0 0,0 4 0 0 0,-6 6 0 0 0,0 1 0 0 0,3 3 0 0 0,0-2 0 0 0,3-2 0 0 0,4-9 0 0 0,3-12 0 0 0,2-13 0 0 0,3-12 0 0 0,1-8 0 0 0,-4-2 0 0 0,-1 4 0 0 0,0 3 0 0 0,-7 13 0 0 0,-2 10 0 0 0,1 17 0 0 0,3 12 0 0 0,4 7 0 0 0,2 5 0 0 0,2 2 0 0 0,2 1 0 0 0,0-1 0 0 0,0-9 0 0 0,1-12 0 0 0,-1-17 0 0 0,1-14 0 0 0,-1-12 0 0 0,0-5 0 0 0,0-3 0 0 0,0-3 0 0 0,0 1 0 0 0,0 1 0 0 0,0 8 0 0 0,-4 5 0 0 0,-2 9 0 0 0,-3 12 0 0 0,-1 8 0 0 0,-3 4 0 0 0,1-2 0 0 0,2-5 0 0 0,3-6 0 0 0,3-2 0 0 0,2-6 0 0 0,1-9 0 0 0,1-7 0 0 0,1-3 0 0 0,-1-3 0 0 0,1 1 0 0 0,-1-1 0 0 0,0 2 0 0 0,1 0 0 0 0,-1 2 0 0 0,0-2 0 0 0,0 3 0 0 0,0-2 0 0 0,0 1 0 0 0,0 4 0 0 0,0 2 0 0 0,0-1 0 0 0,0 0 0 0 0,0 1 0 0 0,0 3 0 0 0,0-4 0 0 0,0 0 0 0 0,0-2 0 0 0,0-1 0 0 0,0 2 0 0 0,0-2 0 0 0,0-3 0 0 0,0-4 0 0 0,0-4 0 0 0,0-1 0 0 0,0-2 0 0 0,0-1 0 0 0,0-1 0 0 0,0 5 0 0 0,-5 5 0 0 0,0 2 0 0 0,-1-1 0 0 0,2 2 0 0 0,1-2 0 0 0,-3 3 0 0 0,-1-1 0 0 0,1 2 0 0 0,2-7 0 0 0</inkml:trace>
-</inkml:ink>
-</file>
-
-<file path=ppt/ink/ink3.xml><?xml version="1.0" encoding="utf-8"?>
-<inkml:ink xmlns:inkml="http://www.w3.org/2003/InkML">
-  <inkml:definitions>
-    <inkml:context xml:id="ctx0">
-      <inkml:inkSource xml:id="inkSrc0">
-        <inkml:traceFormat>
-          <inkml:channel name="X" type="integer" min="-2.14748E9" max="2.14748E9" units="cm"/>
-          <inkml:channel name="Y" type="integer" min="-2.14748E9" max="2.14748E9" units="cm"/>
-          <inkml:channel name="F" type="integer" max="32767" units="dev"/>
-          <inkml:channel name="OA" type="integer" max="360" units="deg"/>
-          <inkml:channel name="OE" type="integer" max="90" units="deg"/>
-        </inkml:traceFormat>
-        <inkml:channelProperties>
-          <inkml:channelProperty channel="X" name="resolution" value="1000" units="1/cm"/>
-          <inkml:channelProperty channel="Y" name="resolution" value="1000" units="1/cm"/>
-          <inkml:channelProperty channel="F" name="resolution" value="0" units="1/dev"/>
-          <inkml:channelProperty channel="OA" name="resolution" value="1000" units="1/deg"/>
-          <inkml:channelProperty channel="OE" name="resolution" value="1000" units="1/deg"/>
-        </inkml:channelProperties>
-      </inkml:inkSource>
-    </inkml:context>
-    <inkml:brush xml:id="br0">
-      <inkml:brushProperty name="width" value="0.1" units="cm"/>
-      <inkml:brushProperty name="height" value="0.1" units="cm"/>
-    </inkml:brush>
-  </inkml:definitions>
-  <inkml:trace contextRef="#ctx0" brushRef="#br0">9366 5821 16383 0 0,'9'4'0'0'0,"11"2"0"0"0,15-1 0 0 0,19 4 0 0 0,26 8 0 0 0,20 2 0 0 0,33 2 0 0 0,27-3 0 0 0,21-5 0 0 0,22-4 0 0 0,12-3 0 0 0,2-4 0 0 0,-4-1 0 0 0,-18-1 0 0 0,-25 3 0 0 0,-32 2 0 0 0,-32-1 0 0 0,-25 0 0 0 0,-17-1 0 0 0,9-1 0 0 0,15-1 0 0 0,14-1 0 0 0,14 0 0 0 0,18 0 0 0 0,4 0 0 0 0,-5-1 0 0 0,-21 1 0 0 0,-21 0 0 0 0,-8 0 0 0 0,3 0 0 0 0,-5 0 0 0 0,-3 0 0 0 0,-11 4 0 0 0,-16 2 0 0 0</inkml:trace>
-</inkml:ink>
-</file>
-
-<file path=ppt/ink/ink4.xml><?xml version="1.0" encoding="utf-8"?>
-<inkml:ink xmlns:inkml="http://www.w3.org/2003/InkML">
-  <inkml:definitions>
-    <inkml:context xml:id="ctx0">
-      <inkml:inkSource xml:id="inkSrc0">
-        <inkml:traceFormat>
-          <inkml:channel name="X" type="integer" min="-2.14748E9" max="2.14748E9" units="cm"/>
-          <inkml:channel name="Y" type="integer" min="-2.14748E9" max="2.14748E9" units="cm"/>
-          <inkml:channel name="F" type="integer" max="32767" units="dev"/>
-          <inkml:channel name="OA" type="integer" max="360" units="deg"/>
-          <inkml:channel name="OE" type="integer" max="90" units="deg"/>
-        </inkml:traceFormat>
-        <inkml:channelProperties>
-          <inkml:channelProperty channel="X" name="resolution" value="1000" units="1/cm"/>
-          <inkml:channelProperty channel="Y" name="resolution" value="1000" units="1/cm"/>
-          <inkml:channelProperty channel="F" name="resolution" value="0" units="1/dev"/>
-          <inkml:channelProperty channel="OA" name="resolution" value="1000" units="1/deg"/>
-          <inkml:channelProperty channel="OE" name="resolution" value="1000" units="1/deg"/>
-        </inkml:channelProperties>
-      </inkml:inkSource>
-    </inkml:context>
-    <inkml:brush xml:id="br0">
-      <inkml:brushProperty name="width" value="0.1" units="cm"/>
-      <inkml:brushProperty name="height" value="0.1" units="cm"/>
-    </inkml:brush>
-  </inkml:definitions>
-  <inkml:trace contextRef="#ctx0" brushRef="#br0">15124 4577 16383 0 0,'4'0'0'0'0,"2"9"0"0"0,-1 11 0 0 0,-4 15 0 0 0,-8 19 0 0 0,-11 26 0 0 0,-11 24 0 0 0,0 35 0 0 0,0 22 0 0 0,5 23 0 0 0,7 14 0 0 0,6 4 0 0 0,5 1 0 0 0,3-7 0 0 0,3-17 0 0 0,-8-3 0 0 0,-2-7 0 0 0,1-6 0 0 0,1 12 0 0 0,2 15 0 0 0,3 22 0 0 0,1 18 0 0 0,1 13 0 0 0,1-1 0 0 0,1-7 0 0 0,-1-22 0 0 0,5-22 0 0 0,1-30 0 0 0,0-30 0 0 0,-2-33 0 0 0,-1-16 0 0 0,-1-13 0 0 0,-1-10 0 0 0,-5-2 0 0 0,-1-2 0 0 0,3-28 0 0 0,16-48 0 0 0,14-51 0 0 0,6-34 0 0 0,7-34 0 0 0,3-22 0 0 0,0-6 0 0 0,5 4 0 0 0,-2 14 0 0 0,-8 23 0 0 0,-3 24 0 0 0,-3 22 0 0 0,-7 20 0 0 0,-8 12 0 0 0,-7 6 0 0 0,-1-3 0 0 0,-3-11 0 0 0,7-17 0 0 0,0-13 0 0 0,7-17 0 0 0,4-8 0 0 0,11-16 0 0 0,-1 6 0 0 0,-3 7 0 0 0,3 5 0 0 0,-1 18 0 0 0,3 23 0 0 0,7 25 0 0 0,23 19 0 0 0,29 14 0 0 0,46 30 0 0 0,41 29 0 0 0,33 15 0 0 0,18 10 0 0 0,12 14 0 0 0,-19 0 0 0 0,-39-14 0 0 0,-30-7 0 0 0,-33-10 0 0 0,-35-7 0 0 0,-31 2 0 0 0,-22 1 0 0 0,-18 4 0 0 0,-11 14 0 0 0,-7 30 0 0 0,-5 27 0 0 0,0 27 0 0 0,-1 16 0 0 0,2 19 0 0 0,0-1 0 0 0,2 0 0 0 0,0-9 0 0 0,0-26 0 0 0,1-32 0 0 0,0-27 0 0 0,1-25 0 0 0,-1-16 0 0 0,0-9 0 0 0,-4-11 0 0 0,-2-8 0 0 0,1-3 0 0 0,0-1 0 0 0,2 0 0 0 0,-3 1 0 0 0,-1-4 0 0 0</inkml:trace>
-</inkml:ink>
-</file>
-
-<file path=ppt/ink/ink5.xml><?xml version="1.0" encoding="utf-8"?>
-<inkml:ink xmlns:inkml="http://www.w3.org/2003/InkML">
-  <inkml:definitions>
-    <inkml:context xml:id="ctx0">
-      <inkml:inkSource xml:id="inkSrc0">
-        <inkml:traceFormat>
-          <inkml:channel name="X" type="integer" min="-2.14748E9" max="2.14748E9" units="cm"/>
-          <inkml:channel name="Y" type="integer" min="-2.14748E9" max="2.14748E9" units="cm"/>
-          <inkml:channel name="F" type="integer" max="32767" units="dev"/>
-          <inkml:channel name="OA" type="integer" max="360" units="deg"/>
-          <inkml:channel name="OE" type="integer" max="90" units="deg"/>
-        </inkml:traceFormat>
-        <inkml:channelProperties>
-          <inkml:channelProperty channel="X" name="resolution" value="1000" units="1/cm"/>
-          <inkml:channelProperty channel="Y" name="resolution" value="1000" units="1/cm"/>
-          <inkml:channelProperty channel="F" name="resolution" value="0" units="1/dev"/>
-          <inkml:channelProperty channel="OA" name="resolution" value="1000" units="1/deg"/>
-          <inkml:channelProperty channel="OE" name="resolution" value="1000" units="1/deg"/>
-        </inkml:channelProperties>
-      </inkml:inkSource>
-    </inkml:context>
-    <inkml:brush xml:id="br0">
-      <inkml:brushProperty name="width" value="0.1" units="cm"/>
-      <inkml:brushProperty name="height" value="0.1" units="cm"/>
-    </inkml:brush>
-  </inkml:definitions>
-  <inkml:trace contextRef="#ctx0" brushRef="#br0">19579 8073 16383 0 0,'4'5'0'0'0,"41"9"0"0"0,59 24 0 0 0,67 19 0 0 0,57 8 0 0 0,45 9 0 0 0,23-6 0 0 0,-9-12 0 0 0,-31-15 0 0 0,-43-14 0 0 0,-40-12 0 0 0,-36-9 0 0 0,-34-5 0 0 0,-29-7 0 0 0,-19-2 0 0 0,-6-9 0 0 0,-3-10 0 0 0,4-13 0 0 0,6-17 0 0 0,-2-7 0 0 0,2-6 0 0 0,-8 0 0 0 0,-12 5 0 0 0,-12-1 0 0 0,-11-2 0 0 0,-7 7 0 0 0,-4 1 0 0 0,-3-3 0 0 0,-2 2 0 0 0,-12-3 0 0 0,-17-7 0 0 0,-20-4 0 0 0,-19 2 0 0 0,-26 0 0 0 0,-11 5 0 0 0,1 8 0 0 0,10 16 0 0 0,13 6 0 0 0,8 10 0 0 0,8 9 0 0 0,7 8 0 0 0,1 2 0 0 0,-6 2 0 0 0,-13 3 0 0 0,-16 1 0 0 0,-7 2 0 0 0,-13 1 0 0 0,-17 13 0 0 0,-7 21 0 0 0,3 19 0 0 0,15 8 0 0 0,25 2 0 0 0,24 4 0 0 0,25 7 0 0 0,19 4 0 0 0,11 6 0 0 0,9 6 0 0 0,4 4 0 0 0,0 4 0 0 0,0 11 0 0 0,-3 8 0 0 0,-10 14 0 0 0,-1 20 0 0 0,-2 22 0 0 0,-2 16 0 0 0,2 10 0 0 0,6 6 0 0 0,17 2 0 0 0,30-4 0 0 0,30-7 0 0 0,18-19 0 0 0,17-19 0 0 0,12-18 0 0 0,-3-26 0 0 0,-8-26 0 0 0,-16-21 0 0 0,-13-13 0 0 0,-15-15 0 0 0,-12-6 0 0 0,-9-9 0 0 0,-10-4 0 0 0,-6-5 0 0 0,-1-6 0 0 0,1-3 0 0 0,6-4 0 0 0,3-2 0 0 0,-3 0 0 0 0</inkml:trace>
 </inkml:ink>
 </file>
 
@@ -701,7 +565,7 @@
               <a:defRPr/>
             </a:pPr>
             <a:r>
-              <a:rPr lang="en-US"/>
+              <a:rPr lang="en-US" dirty="0"/>
               <a:t>After third debugging, say the “those are my 3” joke</a:t>
             </a:r>
           </a:p>
@@ -788,24 +652,24 @@
           <a:lstStyle/>
           <a:p>
             <a:r>
-              <a:rPr lang="en-US"/>
+              <a:rPr lang="en-US" dirty="0"/>
               <a:t>for “who am you”, explain the whole “the questions where in first person”</a:t>
             </a:r>
           </a:p>
           <a:p>
-            <a:endParaRPr lang="en-US"/>
-          </a:p>
-          <a:p>
-            <a:r>
-              <a:rPr lang="en-US"/>
+            <a:endParaRPr lang="en-US" dirty="0"/>
+          </a:p>
+          <a:p>
+            <a:r>
+              <a:rPr lang="en-US" dirty="0"/>
               <a:t>Explain reason chose </a:t>
             </a:r>
             <a:r>
-              <a:rPr lang="en-US" err="1"/>
+              <a:rPr lang="en-US" dirty="0" err="1"/>
               <a:t>shipchannel</a:t>
             </a:r>
             <a:r>
-              <a:rPr lang="en-US"/>
+              <a:rPr lang="en-US" dirty="0"/>
               <a:t>?</a:t>
             </a:r>
           </a:p>
@@ -892,15 +756,15 @@
           <a:lstStyle/>
           <a:p>
             <a:r>
-              <a:rPr lang="en-US"/>
+              <a:rPr lang="en-US" dirty="0"/>
               <a:t>More </a:t>
             </a:r>
             <a:r>
-              <a:rPr lang="en-US" err="1"/>
+              <a:rPr lang="en-US" dirty="0" err="1"/>
               <a:t>deltais</a:t>
             </a:r>
             <a:r>
-              <a:rPr lang="en-US"/>
+              <a:rPr lang="en-US" dirty="0"/>
               <a:t> on discussions?</a:t>
             </a:r>
           </a:p>
@@ -1019,6 +883,7 @@
               <a:rPr lang="en-US"/>
               <a:t>Click to edit Master title style</a:t>
             </a:r>
+            <a:endParaRPr lang="en-US" dirty="0"/>
           </a:p>
         </p:txBody>
       </p:sp>
@@ -1085,6 +950,7 @@
               <a:rPr lang="en-US"/>
               <a:t>Click to edit Master subtitle style</a:t>
             </a:r>
+            <a:endParaRPr lang="en-US" dirty="0"/>
           </a:p>
         </p:txBody>
       </p:sp>
@@ -1226,6 +1092,7 @@
               <a:rPr lang="en-US"/>
               <a:t>Click to edit Master title style</a:t>
             </a:r>
+            <a:endParaRPr lang="en-US" dirty="0"/>
           </a:p>
         </p:txBody>
       </p:sp>
@@ -1290,6 +1157,7 @@
               <a:rPr lang="en-US"/>
               <a:t>Click icon to add picture</a:t>
             </a:r>
+            <a:endParaRPr lang="en-US" dirty="0"/>
           </a:p>
         </p:txBody>
       </p:sp>
@@ -1511,6 +1379,7 @@
               <a:rPr lang="en-US"/>
               <a:t>Click to edit Master title style</a:t>
             </a:r>
+            <a:endParaRPr lang="en-US" dirty="0"/>
           </a:p>
         </p:txBody>
       </p:sp>
@@ -1751,6 +1620,7 @@
               <a:rPr lang="en-US"/>
               <a:t>Click to edit Master title style</a:t>
             </a:r>
+            <a:endParaRPr lang="en-US" dirty="0"/>
           </a:p>
         </p:txBody>
       </p:sp>
@@ -2077,7 +1947,7 @@
           <a:p>
             <a:pPr lvl="0"/>
             <a:r>
-              <a:rPr lang="en-US" sz="8000">
+              <a:rPr lang="en-US" sz="8000" dirty="0">
                 <a:solidFill>
                   <a:schemeClr val="tx1"/>
                 </a:solidFill>
@@ -2193,7 +2063,7 @@
           <a:p>
             <a:pPr lvl="0" algn="r"/>
             <a:r>
-              <a:rPr lang="en-US" sz="8000">
+              <a:rPr lang="en-US" sz="8000" dirty="0">
                 <a:solidFill>
                   <a:schemeClr val="tx1"/>
                 </a:solidFill>
@@ -2292,6 +2162,7 @@
               <a:rPr lang="en-US"/>
               <a:t>Click to edit Master title style</a:t>
             </a:r>
+            <a:endParaRPr lang="en-US" dirty="0"/>
           </a:p>
         </p:txBody>
       </p:sp>
@@ -2498,6 +2369,7 @@
               <a:rPr lang="en-US"/>
               <a:t>Click to edit Master title style</a:t>
             </a:r>
+            <a:endParaRPr lang="en-US" dirty="0"/>
           </a:p>
         </p:txBody>
       </p:sp>
@@ -3034,6 +2906,7 @@
               <a:rPr lang="en-US"/>
               <a:t>Click to edit Master title style</a:t>
             </a:r>
+            <a:endParaRPr lang="en-US" dirty="0"/>
           </a:p>
         </p:txBody>
       </p:sp>
@@ -3183,6 +3056,7 @@
               <a:rPr lang="en-US"/>
               <a:t>Click icon to add picture</a:t>
             </a:r>
+            <a:endParaRPr lang="en-US" dirty="0"/>
           </a:p>
         </p:txBody>
       </p:sp>
@@ -3399,6 +3273,7 @@
               <a:rPr lang="en-US"/>
               <a:t>Click icon to add picture</a:t>
             </a:r>
+            <a:endParaRPr lang="en-US" dirty="0"/>
           </a:p>
         </p:txBody>
       </p:sp>
@@ -3615,6 +3490,7 @@
               <a:rPr lang="en-US"/>
               <a:t>Click icon to add picture</a:t>
             </a:r>
+            <a:endParaRPr lang="en-US" dirty="0"/>
           </a:p>
         </p:txBody>
       </p:sp>
@@ -3799,6 +3675,7 @@
               <a:rPr lang="en-US"/>
               <a:t>Click to edit Master title style</a:t>
             </a:r>
+            <a:endParaRPr lang="en-US" dirty="0"/>
           </a:p>
         </p:txBody>
       </p:sp>
@@ -3855,6 +3732,7 @@
               <a:rPr lang="en-US"/>
               <a:t>Fifth level</a:t>
             </a:r>
+            <a:endParaRPr lang="en-US" dirty="0"/>
           </a:p>
         </p:txBody>
       </p:sp>
@@ -4011,6 +3889,7 @@
               <a:rPr lang="en-US"/>
               <a:t>Click to edit Master title style</a:t>
             </a:r>
+            <a:endParaRPr lang="en-US" dirty="0"/>
           </a:p>
         </p:txBody>
       </p:sp>
@@ -4067,6 +3946,7 @@
               <a:rPr lang="en-US"/>
               <a:t>Fifth level</a:t>
             </a:r>
+            <a:endParaRPr lang="en-US" dirty="0"/>
           </a:p>
         </p:txBody>
       </p:sp>
@@ -4203,6 +4083,7 @@
               <a:rPr lang="en-US"/>
               <a:t>Click to edit Master title style</a:t>
             </a:r>
+            <a:endParaRPr lang="en-US" dirty="0"/>
           </a:p>
         </p:txBody>
       </p:sp>
@@ -4254,6 +4135,7 @@
               <a:rPr lang="en-US"/>
               <a:t>Fifth level</a:t>
             </a:r>
+            <a:endParaRPr lang="en-US" dirty="0"/>
           </a:p>
         </p:txBody>
       </p:sp>
@@ -4412,6 +4294,7 @@
               <a:rPr lang="en-US"/>
               <a:t>Click to edit Master title style</a:t>
             </a:r>
+            <a:endParaRPr lang="en-US" dirty="0"/>
           </a:p>
         </p:txBody>
       </p:sp>
@@ -4669,6 +4552,7 @@
               <a:rPr lang="en-US"/>
               <a:t>Click to edit Master title style</a:t>
             </a:r>
+            <a:endParaRPr lang="en-US" dirty="0"/>
           </a:p>
         </p:txBody>
       </p:sp>
@@ -4725,6 +4609,7 @@
               <a:rPr lang="en-US"/>
               <a:t>Fifth level</a:t>
             </a:r>
+            <a:endParaRPr lang="en-US" dirty="0"/>
           </a:p>
         </p:txBody>
       </p:sp>
@@ -4781,6 +4666,7 @@
               <a:rPr lang="en-US"/>
               <a:t>Fifth level</a:t>
             </a:r>
+            <a:endParaRPr lang="en-US" dirty="0"/>
           </a:p>
         </p:txBody>
       </p:sp>
@@ -4903,6 +4789,7 @@
               <a:rPr lang="en-US"/>
               <a:t>Click to edit Master title style</a:t>
             </a:r>
+            <a:endParaRPr lang="en-US" dirty="0"/>
           </a:p>
         </p:txBody>
       </p:sp>
@@ -5030,6 +4917,7 @@
               <a:rPr lang="en-US"/>
               <a:t>Fifth level</a:t>
             </a:r>
+            <a:endParaRPr lang="en-US" dirty="0"/>
           </a:p>
         </p:txBody>
       </p:sp>
@@ -5157,6 +5045,7 @@
               <a:rPr lang="en-US"/>
               <a:t>Fifth level</a:t>
             </a:r>
+            <a:endParaRPr lang="en-US" dirty="0"/>
           </a:p>
         </p:txBody>
       </p:sp>
@@ -5274,6 +5163,7 @@
               <a:rPr lang="en-US"/>
               <a:t>Click to edit Master title style</a:t>
             </a:r>
+            <a:endParaRPr lang="en-US" dirty="0"/>
           </a:p>
         </p:txBody>
       </p:sp>
@@ -5495,6 +5385,7 @@
               <a:rPr lang="en-US"/>
               <a:t>Click to edit Master title style</a:t>
             </a:r>
+            <a:endParaRPr lang="en-US" dirty="0"/>
           </a:p>
         </p:txBody>
       </p:sp>
@@ -5551,6 +5442,7 @@
               <a:rPr lang="en-US"/>
               <a:t>Fifth level</a:t>
             </a:r>
+            <a:endParaRPr lang="en-US" dirty="0"/>
           </a:p>
         </p:txBody>
       </p:sp>
@@ -5742,6 +5634,7 @@
               <a:rPr lang="en-US"/>
               <a:t>Click to edit Master title style</a:t>
             </a:r>
+            <a:endParaRPr lang="en-US" dirty="0"/>
           </a:p>
         </p:txBody>
       </p:sp>
@@ -5806,6 +5699,7 @@
               <a:rPr lang="en-US"/>
               <a:t>Click icon to add picture</a:t>
             </a:r>
+            <a:endParaRPr lang="en-US" dirty="0"/>
           </a:p>
         </p:txBody>
       </p:sp>
@@ -6033,6 +5927,7 @@
               <a:rPr lang="en-US"/>
               <a:t>Click to edit Master title style</a:t>
             </a:r>
+            <a:endParaRPr lang="en-US" dirty="0"/>
           </a:p>
         </p:txBody>
       </p:sp>
@@ -6094,6 +5989,7 @@
               <a:rPr lang="en-US"/>
               <a:t>Fifth level</a:t>
             </a:r>
+            <a:endParaRPr lang="en-US" dirty="0"/>
           </a:p>
         </p:txBody>
       </p:sp>
@@ -6578,14 +6474,14 @@
           <a:lstStyle/>
           <a:p>
             <a:r>
-              <a:rPr lang="en-US"/>
+              <a:rPr lang="en-US" dirty="0"/>
               <a:t>Charlie’s</a:t>
             </a:r>
             <a:br>
-              <a:rPr lang="en-US"/>
+              <a:rPr lang="en-US" dirty="0"/>
             </a:br>
             <a:r>
-              <a:rPr lang="en-US"/>
+              <a:rPr lang="en-US" dirty="0"/>
               <a:t>Spring Term Presentation</a:t>
             </a:r>
           </a:p>
@@ -6784,7 +6680,7 @@
           </a:lstStyle>
           <a:p>
             <a:r>
-              <a:rPr lang="en-US"/>
+              <a:rPr lang="en-US" dirty="0"/>
               <a:t>Charlie</a:t>
             </a:r>
           </a:p>
@@ -6983,7 +6879,7 @@
           </a:lstStyle>
           <a:p>
             <a:r>
-              <a:rPr lang="en-US"/>
+              <a:rPr lang="en-US" dirty="0"/>
               <a:t>Hatch</a:t>
             </a:r>
           </a:p>
@@ -7182,7 +7078,7 @@
           </a:lstStyle>
           <a:p>
             <a:r>
-              <a:rPr lang="en-US" sz="2800" b="1"/>
+              <a:rPr lang="en-US" sz="2800" b="1" dirty="0"/>
               <a:t>B</a:t>
             </a:r>
           </a:p>
@@ -7381,7 +7277,7 @@
           </a:lstStyle>
           <a:p>
             <a:r>
-              <a:rPr lang="en-US" sz="2800" b="1"/>
+              <a:rPr lang="en-US" sz="2800" b="1" dirty="0"/>
               <a:t>y</a:t>
             </a:r>
           </a:p>
@@ -7982,7 +7878,7 @@
           <a:lstStyle/>
           <a:p>
             <a:r>
-              <a:rPr lang="en-US"/>
+              <a:rPr lang="en-US" dirty="0"/>
               <a:t>Tech: Advanced app-dev</a:t>
             </a:r>
           </a:p>
@@ -8012,57 +7908,57 @@
           <a:lstStyle/>
           <a:p>
             <a:r>
-              <a:rPr lang="en-US"/>
+              <a:rPr lang="en-US" dirty="0"/>
               <a:t>We worked on two things in advanced </a:t>
             </a:r>
             <a:r>
-              <a:rPr lang="en-US" err="1"/>
+              <a:rPr lang="en-US" dirty="0" err="1"/>
               <a:t>appdev</a:t>
             </a:r>
             <a:r>
-              <a:rPr lang="en-US"/>
+              <a:rPr lang="en-US" dirty="0"/>
               <a:t>.</a:t>
             </a:r>
           </a:p>
           <a:p>
             <a:pPr lvl="1"/>
             <a:r>
-              <a:rPr lang="en-US"/>
+              <a:rPr lang="en-US" dirty="0"/>
               <a:t>One of the projects we worked on was the Snack Shack</a:t>
             </a:r>
           </a:p>
           <a:p>
             <a:pPr lvl="2"/>
             <a:r>
-              <a:rPr lang="en-US"/>
+              <a:rPr lang="en-US" dirty="0"/>
               <a:t>In actuality, the most major was, as discussed by Ryan, actually databases and SQL. But I figured you have heard about that from him</a:t>
             </a:r>
           </a:p>
           <a:p>
             <a:pPr lvl="1"/>
             <a:r>
-              <a:rPr lang="en-US"/>
+              <a:rPr lang="en-US" dirty="0"/>
               <a:t>Tasks used:</a:t>
             </a:r>
           </a:p>
           <a:p>
             <a:pPr lvl="2"/>
             <a:r>
-              <a:rPr lang="en-US"/>
+              <a:rPr lang="en-US" dirty="0"/>
               <a:t>Debugging</a:t>
             </a:r>
           </a:p>
           <a:p>
             <a:pPr lvl="3"/>
             <a:r>
-              <a:rPr lang="en-US"/>
+              <a:rPr lang="en-US" dirty="0"/>
               <a:t>Debugging</a:t>
             </a:r>
           </a:p>
           <a:p>
             <a:pPr lvl="3"/>
             <a:r>
-              <a:rPr lang="en-US"/>
+              <a:rPr lang="en-US" dirty="0"/>
               <a:t>Debugging</a:t>
             </a:r>
           </a:p>
@@ -8071,34 +7967,34 @@
               <a:buNone/>
             </a:pPr>
             <a:r>
-              <a:rPr lang="en-US"/>
+              <a:rPr lang="en-US" dirty="0"/>
               <a:t>Okay, in all seriousness</a:t>
             </a:r>
           </a:p>
           <a:p>
             <a:pPr lvl="2"/>
             <a:r>
-              <a:rPr lang="en-US"/>
+              <a:rPr lang="en-US" dirty="0"/>
               <a:t>Critical Thinking</a:t>
             </a:r>
           </a:p>
           <a:p>
             <a:pPr lvl="2"/>
             <a:r>
-              <a:rPr lang="en-US"/>
+              <a:rPr lang="en-US" dirty="0"/>
               <a:t>Trial and Error</a:t>
             </a:r>
           </a:p>
           <a:p>
             <a:pPr lvl="2"/>
-            <a:endParaRPr lang="en-US"/>
+            <a:endParaRPr lang="en-US" dirty="0"/>
           </a:p>
           <a:p>
             <a:pPr marL="0" indent="0">
               <a:buNone/>
             </a:pPr>
             <a:r>
-              <a:rPr lang="en-US"/>
+              <a:rPr lang="en-US" dirty="0"/>
               <a:t>As for what I gained, it’s mostly just more knowledge, in this case about SQL</a:t>
             </a:r>
           </a:p>
@@ -8156,8 +8052,12 @@
           <a:lstStyle/>
           <a:p>
             <a:r>
-              <a:rPr lang="en-US"/>
-              <a:t>Core: Community</a:t>
+              <a:rPr lang="en-US" dirty="0"/>
+              <a:t>Core</a:t>
+            </a:r>
+            <a:r>
+              <a:rPr lang="en-US"/>
+              <a:t>: Community</a:t>
             </a:r>
           </a:p>
         </p:txBody>
@@ -8184,35 +8084,40 @@
           <a:lstStyle/>
           <a:p>
             <a:r>
-              <a:rPr lang="en-US"/>
+              <a:rPr lang="en-US" dirty="0"/>
               <a:t>In community, we learned about, well, our community.</a:t>
             </a:r>
           </a:p>
           <a:p>
             <a:r>
-              <a:rPr lang="en-US"/>
+              <a:rPr lang="en-US" dirty="0"/>
               <a:t>While not inherently a skill: </a:t>
             </a:r>
           </a:p>
           <a:p>
             <a:pPr lvl="1"/>
             <a:r>
-              <a:rPr lang="en-US"/>
+              <a:rPr lang="en-US" dirty="0"/>
               <a:t>I learned more about the greater Houston area</a:t>
             </a:r>
           </a:p>
           <a:p>
             <a:pPr lvl="1"/>
             <a:r>
-              <a:rPr lang="en-US"/>
+              <a:rPr lang="en-US" dirty="0"/>
               <a:t>I made a nice slideshow about Charlie Serbia called “who am you”</a:t>
             </a:r>
           </a:p>
           <a:p>
             <a:r>
-              <a:rPr lang="en-US"/>
-              <a:t>As for how I’d use it, well, it just helps to know what’s around you so you can actually do things. Basically, less “use it” and more “add more things to use skills on”</a:t>
-            </a:r>
+              <a:rPr lang="en-US" dirty="0"/>
+              <a:t>As for how I’d use it, well, it just helps to know what’s around you so you can actually do things. Basically, less “use it” and more “add more things to </a:t>
+            </a:r>
+            <a:r>
+              <a:rPr lang="en-US"/>
+              <a:t>use skills on”</a:t>
+            </a:r>
+            <a:endParaRPr lang="en-US" dirty="0"/>
           </a:p>
         </p:txBody>
       </p:sp>
@@ -8268,7 +8173,7 @@
           <a:lstStyle/>
           <a:p>
             <a:r>
-              <a:rPr lang="en-US"/>
+              <a:rPr lang="en-US" dirty="0"/>
               <a:t>Club: star-trek club</a:t>
             </a:r>
           </a:p>
@@ -8299,17 +8204,22 @@
               <a:buNone/>
             </a:pPr>
             <a:r>
-              <a:rPr lang="en-US"/>
+              <a:rPr lang="en-US" dirty="0"/>
               <a:t>Well, while there where many good </a:t>
             </a:r>
             <a:r>
-              <a:rPr lang="en-US" err="1"/>
+              <a:rPr lang="en-US" dirty="0" err="1"/>
               <a:t>memorys</a:t>
             </a:r>
             <a:r>
-              <a:rPr lang="en-US"/>
-              <a:t>, I think one of my favorites had to have been some of the discussions we had about Data, specifically the fact that he does have emotions, contrary to his own statments</a:t>
-            </a:r>
+              <a:rPr lang="en-US" dirty="0"/>
+              <a:t>, I think one of my favorites had to have been some of the discussions we had about Data, specifically the fact that he does have emotions, contrary to his own </a:t>
+            </a:r>
+            <a:r>
+              <a:rPr lang="en-US"/>
+              <a:t>statments</a:t>
+            </a:r>
+            <a:endParaRPr lang="en-US" dirty="0"/>
           </a:p>
         </p:txBody>
       </p:sp>
@@ -8403,15 +8313,23 @@
             <a:pPr marL="0" indent="0">
               <a:buNone/>
             </a:pPr>
-            <a:endParaRPr lang="en-US"/>
+            <a:endParaRPr lang="en-US" dirty="0"/>
           </a:p>
           <a:p>
             <a:pPr marL="0" indent="0">
               <a:buNone/>
             </a:pPr>
             <a:r>
-              <a:rPr lang="en-US"/>
-              <a:t>That is my "dynamic file path" system. There's no easy way  show an image of it, but long story short basically it allows saving a file within the inside of a programs folder structure.</a:t>
+              <a:rPr lang="en-US" dirty="0"/>
+              <a:t>That is my "dynamic file path" system. There's no easy way  show an image of </a:t>
+            </a:r>
+            <a:r>
+              <a:rPr lang="en-US"/>
+              <a:t>it, but long story short basically it allows </a:t>
+            </a:r>
+            <a:r>
+              <a:rPr lang="en-US" dirty="0"/>
+              <a:t>saving a file within the inside of a programs folder structure.</a:t>
             </a:r>
           </a:p>
           <a:p>
@@ -8422,6 +8340,7 @@
               <a:rPr lang="en-US"/>
               <a:t> </a:t>
             </a:r>
+            <a:endParaRPr lang="en-US" dirty="0"/>
           </a:p>
         </p:txBody>
       </p:sp>
@@ -8435,525 +8354,6 @@
   <p:clrMapOvr>
     <a:masterClrMapping/>
   </p:clrMapOvr>
-</p:sld>
-</file>
-
-<file path=ppt/slides/slide6.xml><?xml version="1.0" encoding="utf-8"?>
-<p:sld xmlns:a="http://schemas.openxmlformats.org/drawingml/2006/main" xmlns:r="http://schemas.openxmlformats.org/officeDocument/2006/relationships" xmlns:p="http://schemas.openxmlformats.org/presentationml/2006/main">
-  <p:cSld>
-    <p:spTree>
-      <p:nvGrpSpPr>
-        <p:cNvPr id="1" name=""/>
-        <p:cNvGrpSpPr/>
-        <p:nvPr/>
-      </p:nvGrpSpPr>
-      <p:grpSpPr>
-        <a:xfrm>
-          <a:off x="0" y="0"/>
-          <a:ext cx="0" cy="0"/>
-          <a:chOff x="0" y="0"/>
-          <a:chExt cx="0" cy="0"/>
-        </a:xfrm>
-      </p:grpSpPr>
-      <mc:AlternateContent xmlns:mc="http://schemas.openxmlformats.org/markup-compatibility/2006">
-        <mc:Choice xmlns:p14="http://schemas.microsoft.com/office/powerpoint/2010/main" Requires="p14">
-          <p:contentPart p14:bwMode="auto" r:id="rId2">
-            <p14:nvContentPartPr>
-              <p14:cNvPr id="4" name="Ink 3">
-                <a:extLst>
-                  <a:ext uri="{FF2B5EF4-FFF2-40B4-BE49-F238E27FC236}">
-                    <a16:creationId xmlns:a16="http://schemas.microsoft.com/office/drawing/2014/main" id="{1EDF980B-B73B-E6F1-BD42-856A30A6BE57}"/>
-                  </a:ext>
-                </a:extLst>
-              </p14:cNvPr>
-              <p14:cNvContentPartPr/>
-              <p14:nvPr/>
-            </p14:nvContentPartPr>
-            <p14:xfrm>
-              <a:off x="2722977" y="1106714"/>
-              <a:ext cx="143593" cy="1788285"/>
-            </p14:xfrm>
-          </p:contentPart>
-        </mc:Choice>
-        <mc:Fallback>
-          <p:pic>
-            <p:nvPicPr>
-              <p:cNvPr id="4" name="Ink 3">
-                <a:extLst>
-                  <a:ext uri="{FF2B5EF4-FFF2-40B4-BE49-F238E27FC236}">
-                    <a16:creationId xmlns:a16="http://schemas.microsoft.com/office/drawing/2014/main" id="{1EDF980B-B73B-E6F1-BD42-856A30A6BE57}"/>
-                  </a:ext>
-                </a:extLst>
-              </p:cNvPr>
-              <p:cNvPicPr/>
-              <p:nvPr/>
-            </p:nvPicPr>
-            <p:blipFill>
-              <a:blip r:embed="rId3"/>
-              <a:stretch>
-                <a:fillRect/>
-              </a:stretch>
-            </p:blipFill>
-            <p:spPr>
-              <a:xfrm>
-                <a:off x="2705387" y="1089076"/>
-                <a:ext cx="179132" cy="1823921"/>
-              </a:xfrm>
-              <a:prstGeom prst="rect">
-                <a:avLst/>
-              </a:prstGeom>
-            </p:spPr>
-          </p:pic>
-        </mc:Fallback>
-      </mc:AlternateContent>
-      <mc:AlternateContent xmlns:mc="http://schemas.openxmlformats.org/markup-compatibility/2006">
-        <mc:Choice xmlns:p14="http://schemas.microsoft.com/office/powerpoint/2010/main" Requires="p14">
-          <p:contentPart p14:bwMode="auto" r:id="rId4">
-            <p14:nvContentPartPr>
-              <p14:cNvPr id="5" name="Ink 4">
-                <a:extLst>
-                  <a:ext uri="{FF2B5EF4-FFF2-40B4-BE49-F238E27FC236}">
-                    <a16:creationId xmlns:a16="http://schemas.microsoft.com/office/drawing/2014/main" id="{757EC4C2-30F1-69FF-4C46-86AF837196B1}"/>
-                  </a:ext>
-                </a:extLst>
-              </p14:cNvPr>
-              <p14:cNvContentPartPr/>
-              <p14:nvPr/>
-            </p14:nvContentPartPr>
-            <p14:xfrm>
-              <a:off x="1814285" y="1442357"/>
-              <a:ext cx="1370258" cy="58012"/>
-            </p14:xfrm>
-          </p:contentPart>
-        </mc:Choice>
-        <mc:Fallback>
-          <p:pic>
-            <p:nvPicPr>
-              <p:cNvPr id="5" name="Ink 4">
-                <a:extLst>
-                  <a:ext uri="{FF2B5EF4-FFF2-40B4-BE49-F238E27FC236}">
-                    <a16:creationId xmlns:a16="http://schemas.microsoft.com/office/drawing/2014/main" id="{757EC4C2-30F1-69FF-4C46-86AF837196B1}"/>
-                  </a:ext>
-                </a:extLst>
-              </p:cNvPr>
-              <p:cNvPicPr/>
-              <p:nvPr/>
-            </p:nvPicPr>
-            <p:blipFill>
-              <a:blip r:embed="rId5"/>
-              <a:stretch>
-                <a:fillRect/>
-              </a:stretch>
-            </p:blipFill>
-            <p:spPr>
-              <a:xfrm>
-                <a:off x="1796288" y="1424810"/>
-                <a:ext cx="1405891" cy="93464"/>
-              </a:xfrm>
-              <a:prstGeom prst="rect">
-                <a:avLst/>
-              </a:prstGeom>
-            </p:spPr>
-          </p:pic>
-        </mc:Fallback>
-      </mc:AlternateContent>
-      <mc:AlternateContent xmlns:mc="http://schemas.openxmlformats.org/markup-compatibility/2006">
-        <mc:Choice xmlns:p14="http://schemas.microsoft.com/office/powerpoint/2010/main" Requires="p14">
-          <p:contentPart p14:bwMode="auto" r:id="rId6">
-            <p14:nvContentPartPr>
-              <p14:cNvPr id="6" name="Ink 5">
-                <a:extLst>
-                  <a:ext uri="{FF2B5EF4-FFF2-40B4-BE49-F238E27FC236}">
-                    <a16:creationId xmlns:a16="http://schemas.microsoft.com/office/drawing/2014/main" id="{AE39F47C-F515-1FC1-718E-2E6AFEA24484}"/>
-                  </a:ext>
-                </a:extLst>
-              </p14:cNvPr>
-              <p14:cNvContentPartPr/>
-              <p14:nvPr/>
-            </p14:nvContentPartPr>
-            <p14:xfrm>
-              <a:off x="3718586" y="1016000"/>
-              <a:ext cx="1051290" cy="1850280"/>
-            </p14:xfrm>
-          </p:contentPart>
-        </mc:Choice>
-        <mc:Fallback>
-          <p:pic>
-            <p:nvPicPr>
-              <p:cNvPr id="6" name="Ink 5">
-                <a:extLst>
-                  <a:ext uri="{FF2B5EF4-FFF2-40B4-BE49-F238E27FC236}">
-                    <a16:creationId xmlns:a16="http://schemas.microsoft.com/office/drawing/2014/main" id="{AE39F47C-F515-1FC1-718E-2E6AFEA24484}"/>
-                  </a:ext>
-                </a:extLst>
-              </p:cNvPr>
-              <p:cNvPicPr/>
-              <p:nvPr/>
-            </p:nvPicPr>
-            <p:blipFill>
-              <a:blip r:embed="rId7"/>
-              <a:stretch>
-                <a:fillRect/>
-              </a:stretch>
-            </p:blipFill>
-            <p:spPr>
-              <a:xfrm>
-                <a:off x="3700591" y="998005"/>
-                <a:ext cx="1086921" cy="1885911"/>
-              </a:xfrm>
-              <a:prstGeom prst="rect">
-                <a:avLst/>
-              </a:prstGeom>
-            </p:spPr>
-          </p:pic>
-        </mc:Fallback>
-      </mc:AlternateContent>
-      <mc:AlternateContent xmlns:mc="http://schemas.openxmlformats.org/markup-compatibility/2006">
-        <mc:Choice xmlns:p14="http://schemas.microsoft.com/office/powerpoint/2010/main" Requires="p14">
-          <p:contentPart p14:bwMode="auto" r:id="rId8">
-            <p14:nvContentPartPr>
-              <p14:cNvPr id="7" name="Ink 6">
-                <a:extLst>
-                  <a:ext uri="{FF2B5EF4-FFF2-40B4-BE49-F238E27FC236}">
-                    <a16:creationId xmlns:a16="http://schemas.microsoft.com/office/drawing/2014/main" id="{6583D680-F220-D034-D2CD-0D5E74C9B384}"/>
-                  </a:ext>
-                </a:extLst>
-              </p14:cNvPr>
-              <p14:cNvContentPartPr/>
-              <p14:nvPr/>
-            </p14:nvContentPartPr>
-            <p14:xfrm>
-              <a:off x="5315857" y="1877021"/>
-              <a:ext cx="1029104" cy="1308800"/>
-            </p14:xfrm>
-          </p:contentPart>
-        </mc:Choice>
-        <mc:Fallback>
-          <p:pic>
-            <p:nvPicPr>
-              <p:cNvPr id="7" name="Ink 6">
-                <a:extLst>
-                  <a:ext uri="{FF2B5EF4-FFF2-40B4-BE49-F238E27FC236}">
-                    <a16:creationId xmlns:a16="http://schemas.microsoft.com/office/drawing/2014/main" id="{6583D680-F220-D034-D2CD-0D5E74C9B384}"/>
-                  </a:ext>
-                </a:extLst>
-              </p:cNvPr>
-              <p:cNvPicPr/>
-              <p:nvPr/>
-            </p:nvPicPr>
-            <p:blipFill>
-              <a:blip r:embed="rId9"/>
-              <a:stretch>
-                <a:fillRect/>
-              </a:stretch>
-            </p:blipFill>
-            <p:spPr>
-              <a:xfrm>
-                <a:off x="5297866" y="1859388"/>
-                <a:ext cx="1064727" cy="1344426"/>
-              </a:xfrm>
-              <a:prstGeom prst="rect">
-                <a:avLst/>
-              </a:prstGeom>
-            </p:spPr>
-          </p:pic>
-        </mc:Fallback>
-      </mc:AlternateContent>
-      <p:sp>
-        <p:nvSpPr>
-          <p:cNvPr id="11" name="TextBox 10">
-            <a:extLst>
-              <a:ext uri="{FF2B5EF4-FFF2-40B4-BE49-F238E27FC236}">
-                <a16:creationId xmlns:a16="http://schemas.microsoft.com/office/drawing/2014/main" id="{B9F7FF27-934F-61E9-623E-28E67F7A95BB}"/>
-              </a:ext>
-            </a:extLst>
-          </p:cNvPr>
-          <p:cNvSpPr txBox="1"/>
-          <p:nvPr/>
-        </p:nvSpPr>
-        <p:spPr>
-          <a:xfrm>
-            <a:off x="952500" y="1605642"/>
-            <a:ext cx="10392937" cy="523220"/>
-          </a:xfrm>
-          <a:prstGeom prst="rect">
-            <a:avLst/>
-          </a:prstGeom>
-          <a:noFill/>
-        </p:spPr>
-        <p:txBody>
-          <a:bodyPr rot="0" spcFirstLastPara="0" vertOverflow="overflow" horzOverflow="overflow" vert="horz" wrap="square" lIns="91440" tIns="45720" rIns="91440" bIns="45720" numCol="1" spcCol="0" rtlCol="0" fromWordArt="0" anchor="t" anchorCtr="0" forceAA="0" compatLnSpc="1">
-            <a:prstTxWarp prst="textNoShape">
-              <a:avLst/>
-            </a:prstTxWarp>
-            <a:spAutoFit/>
-          </a:bodyPr>
-          <a:lstStyle/>
-          <a:p>
-            <a:r>
-              <a:rPr lang="en-US" sz="2800" b="1"/>
-              <a:t>And now, what you have all been waiting impatiently for:</a:t>
-            </a:r>
-          </a:p>
-        </p:txBody>
-      </p:sp>
-      <p:sp>
-        <p:nvSpPr>
-          <p:cNvPr id="16" name="TextBox 15">
-            <a:extLst>
-              <a:ext uri="{FF2B5EF4-FFF2-40B4-BE49-F238E27FC236}">
-                <a16:creationId xmlns:a16="http://schemas.microsoft.com/office/drawing/2014/main" id="{6B24E668-FDBC-2A58-E24B-5AFE69FF43EA}"/>
-              </a:ext>
-            </a:extLst>
-          </p:cNvPr>
-          <p:cNvSpPr txBox="1"/>
-          <p:nvPr/>
-        </p:nvSpPr>
-        <p:spPr>
-          <a:xfrm>
-            <a:off x="2861127" y="2594428"/>
-            <a:ext cx="1378858" cy="369332"/>
-          </a:xfrm>
-          <a:prstGeom prst="rect">
-            <a:avLst/>
-          </a:prstGeom>
-          <a:noFill/>
-        </p:spPr>
-        <p:txBody>
-          <a:bodyPr rot="0" spcFirstLastPara="0" vertOverflow="overflow" horzOverflow="overflow" vert="horz" wrap="square" lIns="91440" tIns="45720" rIns="91440" bIns="45720" numCol="1" spcCol="0" rtlCol="0" fromWordArt="0" anchor="t" anchorCtr="0" forceAA="0" compatLnSpc="1">
-            <a:prstTxWarp prst="textNoShape">
-              <a:avLst/>
-            </a:prstTxWarp>
-            <a:spAutoFit/>
-          </a:bodyPr>
-          <a:lstStyle/>
-          <a:p>
-            <a:r>
-              <a:rPr lang="en-US" dirty="0"/>
-              <a:t>The </a:t>
-            </a:r>
-            <a:r>
-              <a:rPr lang="en-US" dirty="0" err="1"/>
-              <a:t>en</a:t>
-            </a:r>
-            <a:r>
-              <a:rPr lang="en-US" dirty="0"/>
-              <a:t>...</a:t>
-            </a:r>
-          </a:p>
-        </p:txBody>
-      </p:sp>
-      <p:sp>
-        <p:nvSpPr>
-          <p:cNvPr id="17" name="TextBox 16">
-            <a:extLst>
-              <a:ext uri="{FF2B5EF4-FFF2-40B4-BE49-F238E27FC236}">
-                <a16:creationId xmlns:a16="http://schemas.microsoft.com/office/drawing/2014/main" id="{C941C5D6-1C32-1CCA-8A25-4DBCADF7A7AF}"/>
-              </a:ext>
-            </a:extLst>
-          </p:cNvPr>
-          <p:cNvSpPr txBox="1"/>
-          <p:nvPr/>
-        </p:nvSpPr>
-        <p:spPr>
-          <a:xfrm>
-            <a:off x="1560285" y="3432627"/>
-            <a:ext cx="3588655" cy="1200329"/>
-          </a:xfrm>
-          <a:prstGeom prst="rect">
-            <a:avLst/>
-          </a:prstGeom>
-          <a:noFill/>
-        </p:spPr>
-        <p:txBody>
-          <a:bodyPr rot="0" spcFirstLastPara="0" vertOverflow="overflow" horzOverflow="overflow" vert="horz" wrap="square" lIns="91440" tIns="45720" rIns="91440" bIns="45720" numCol="1" spcCol="0" rtlCol="0" fromWordArt="0" anchor="t" anchorCtr="0" forceAA="0" compatLnSpc="1">
-            <a:prstTxWarp prst="textNoShape">
-              <a:avLst/>
-            </a:prstTxWarp>
-            <a:spAutoFit/>
-          </a:bodyPr>
-          <a:lstStyle/>
-          <a:p>
-            <a:r>
-              <a:rPr lang="en-US" dirty="0"/>
-              <a:t>Oh, wait, actually, first, the meaning of Life, The Universe, and Everything is, as we all know, 42</a:t>
-            </a:r>
-          </a:p>
-        </p:txBody>
-      </p:sp>
-      <p:sp>
-        <p:nvSpPr>
-          <p:cNvPr id="18" name="TextBox 17">
-            <a:extLst>
-              <a:ext uri="{FF2B5EF4-FFF2-40B4-BE49-F238E27FC236}">
-                <a16:creationId xmlns:a16="http://schemas.microsoft.com/office/drawing/2014/main" id="{61FE8BD0-21F9-4A30-81A2-C2148D1A885A}"/>
-              </a:ext>
-            </a:extLst>
-          </p:cNvPr>
-          <p:cNvSpPr txBox="1"/>
-          <p:nvPr/>
-        </p:nvSpPr>
-        <p:spPr>
-          <a:xfrm>
-            <a:off x="6105072" y="3428999"/>
-            <a:ext cx="3202212" cy="923330"/>
-          </a:xfrm>
-          <a:prstGeom prst="rect">
-            <a:avLst/>
-          </a:prstGeom>
-          <a:noFill/>
-        </p:spPr>
-        <p:txBody>
-          <a:bodyPr rot="0" spcFirstLastPara="0" vertOverflow="overflow" horzOverflow="overflow" vert="horz" wrap="square" lIns="91440" tIns="45720" rIns="91440" bIns="45720" numCol="1" spcCol="0" rtlCol="0" fromWordArt="0" anchor="t" anchorCtr="0" forceAA="0" compatLnSpc="1">
-            <a:prstTxWarp prst="textNoShape">
-              <a:avLst/>
-            </a:prstTxWarp>
-            <a:spAutoFit/>
-          </a:bodyPr>
-          <a:lstStyle/>
-          <a:p>
-            <a:r>
-              <a:rPr lang="en-US" dirty="0"/>
-              <a:t>So, obviously we don't understand the </a:t>
-            </a:r>
-            <a:r>
-              <a:rPr lang="en-US"/>
-              <a:t>question. </a:t>
-            </a:r>
-          </a:p>
-          <a:p>
-            <a:r>
-              <a:rPr lang="en-US" dirty="0"/>
-              <a:t>Well, I found it. </a:t>
-            </a:r>
-            <a:r>
-              <a:rPr lang="en-US"/>
-              <a:t>It is</a:t>
-            </a:r>
-            <a:endParaRPr lang="en-US" dirty="0"/>
-          </a:p>
-        </p:txBody>
-      </p:sp>
-    </p:spTree>
-    <p:extLst>
-      <p:ext uri="{BB962C8B-B14F-4D97-AF65-F5344CB8AC3E}">
-        <p14:creationId xmlns:p14="http://schemas.microsoft.com/office/powerpoint/2010/main" val="411591964"/>
-      </p:ext>
-    </p:extLst>
-  </p:cSld>
-  <p:clrMapOvr>
-    <a:masterClrMapping/>
-  </p:clrMapOvr>
-</p:sld>
-</file>
-
-<file path=ppt/slides/slide7.xml><?xml version="1.0" encoding="utf-8"?>
-<p:sld xmlns:a="http://schemas.openxmlformats.org/drawingml/2006/main" xmlns:r="http://schemas.openxmlformats.org/officeDocument/2006/relationships" xmlns:p="http://schemas.openxmlformats.org/presentationml/2006/main">
-  <p:cSld>
-    <p:spTree>
-      <p:nvGrpSpPr>
-        <p:cNvPr id="1" name=""/>
-        <p:cNvGrpSpPr/>
-        <p:nvPr/>
-      </p:nvGrpSpPr>
-      <p:grpSpPr>
-        <a:xfrm>
-          <a:off x="0" y="0"/>
-          <a:ext cx="0" cy="0"/>
-          <a:chOff x="0" y="0"/>
-          <a:chExt cx="0" cy="0"/>
-        </a:xfrm>
-      </p:grpSpPr>
-      <p:sp>
-        <p:nvSpPr>
-          <p:cNvPr id="4" name="Rectangle 3">
-            <a:extLst>
-              <a:ext uri="{FF2B5EF4-FFF2-40B4-BE49-F238E27FC236}">
-                <a16:creationId xmlns:a16="http://schemas.microsoft.com/office/drawing/2014/main" id="{3BD51B22-6035-47AA-F096-DF50E1293D3E}"/>
-              </a:ext>
-            </a:extLst>
-          </p:cNvPr>
-          <p:cNvSpPr/>
-          <p:nvPr/>
-        </p:nvSpPr>
-        <p:spPr>
-          <a:xfrm>
-            <a:off x="0" y="0"/>
-            <a:ext cx="12192000" cy="6858000"/>
-          </a:xfrm>
-          <a:prstGeom prst="rect">
-            <a:avLst/>
-          </a:prstGeom>
-          <a:solidFill>
-            <a:srgbClr val="1070AA"/>
-          </a:solidFill>
-        </p:spPr>
-        <p:style>
-          <a:lnRef idx="2">
-            <a:schemeClr val="accent1">
-              <a:shade val="15000"/>
-            </a:schemeClr>
-          </a:lnRef>
-          <a:fillRef idx="1">
-            <a:schemeClr val="accent1"/>
-          </a:fillRef>
-          <a:effectRef idx="0">
-            <a:schemeClr val="accent1"/>
-          </a:effectRef>
-          <a:fontRef idx="minor">
-            <a:schemeClr val="lt1"/>
-          </a:fontRef>
-        </p:style>
-        <p:txBody>
-          <a:bodyPr rtlCol="0" anchor="ctr"/>
-          <a:lstStyle/>
-          <a:p>
-            <a:pPr algn="ctr"/>
-            <a:endParaRPr lang="en-US"/>
-          </a:p>
-        </p:txBody>
-      </p:sp>
-      <p:pic>
-        <p:nvPicPr>
-          <p:cNvPr id="3" name="Picture 2" descr="A blue screen with a qr code&#10;&#10;AI-generated content may be incorrect.">
-            <a:extLst>
-              <a:ext uri="{FF2B5EF4-FFF2-40B4-BE49-F238E27FC236}">
-                <a16:creationId xmlns:a16="http://schemas.microsoft.com/office/drawing/2014/main" id="{093AC10B-ECC1-A72C-BD4E-BE5469028DD3}"/>
-              </a:ext>
-            </a:extLst>
-          </p:cNvPr>
-          <p:cNvPicPr>
-            <a:picLocks noChangeAspect="1"/>
-          </p:cNvPicPr>
-          <p:nvPr/>
-        </p:nvPicPr>
-        <p:blipFill>
-          <a:blip r:embed="rId2"/>
-          <a:stretch>
-            <a:fillRect/>
-          </a:stretch>
-        </p:blipFill>
-        <p:spPr>
-          <a:xfrm>
-            <a:off x="1593440" y="1298191"/>
-            <a:ext cx="5324442" cy="3670464"/>
-          </a:xfrm>
-          <a:prstGeom prst="rect">
-            <a:avLst/>
-          </a:prstGeom>
-        </p:spPr>
-      </p:pic>
-    </p:spTree>
-    <p:extLst>
-      <p:ext uri="{BB962C8B-B14F-4D97-AF65-F5344CB8AC3E}">
-        <p14:creationId xmlns:p14="http://schemas.microsoft.com/office/powerpoint/2010/main" val="3833004409"/>
-      </p:ext>
-    </p:extLst>
-  </p:cSld>
-  <p:clrMapOvr>
-    <a:masterClrMapping/>
-  </p:clrMapOvr>
-  <p:transition advClick="0"/>
 </p:sld>
 </file>
 

</xml_diff>